<commit_message>
Fix BXB 005 page 6 label wrapping
</commit_message>
<xml_diff>
--- a/social/Bridge_X_Brief_005_LinkedIn_Carousel.pptx
+++ b/social/Bridge_X_Brief_005_LinkedIn_Carousel.pptx
@@ -2,19 +2,19 @@
 <file path=ppt/presentation.xml><?xml version="1.0" encoding="utf-8"?>
 <p:presentation xmlns:p="http://schemas.openxmlformats.org/presentationml/2006/main">
   <p:sldMasterIdLst>
-    <p:sldMasterId xmlns:r="http://schemas.openxmlformats.org/officeDocument/2006/relationships" id="2147483648" r:id="R9f083f8c900a4a74"/>
+    <p:sldMasterId xmlns:r="http://schemas.openxmlformats.org/officeDocument/2006/relationships" id="2147483648" r:id="Rbc6dc6c77c424500"/>
   </p:sldMasterIdLst>
   <p:notesMasterIdLst>
-    <p:notesMasterId xmlns:r="http://schemas.openxmlformats.org/officeDocument/2006/relationships" r:id="R0a9373822f7442d3"/>
+    <p:notesMasterId xmlns:r="http://schemas.openxmlformats.org/officeDocument/2006/relationships" r:id="Rdb3336a2eb8c4493"/>
   </p:notesMasterIdLst>
   <p:sldIdLst>
-    <p:sldId xmlns:r="http://schemas.openxmlformats.org/officeDocument/2006/relationships" id="256" r:id="Rcd9adc732bce4c27"/>
-    <p:sldId xmlns:r="http://schemas.openxmlformats.org/officeDocument/2006/relationships" id="257" r:id="Re6427d2b38cf4f02"/>
-    <p:sldId xmlns:r="http://schemas.openxmlformats.org/officeDocument/2006/relationships" id="258" r:id="Rc6ea3813fdd84f91"/>
-    <p:sldId xmlns:r="http://schemas.openxmlformats.org/officeDocument/2006/relationships" id="259" r:id="Rb9c381f7fd1f47ae"/>
-    <p:sldId xmlns:r="http://schemas.openxmlformats.org/officeDocument/2006/relationships" id="260" r:id="R38c7303445cb46f0"/>
-    <p:sldId xmlns:r="http://schemas.openxmlformats.org/officeDocument/2006/relationships" id="261" r:id="R77cfb81307e34ab9"/>
-    <p:sldId xmlns:r="http://schemas.openxmlformats.org/officeDocument/2006/relationships" id="262" r:id="Rd047a685e0524a65"/>
+    <p:sldId xmlns:r="http://schemas.openxmlformats.org/officeDocument/2006/relationships" id="256" r:id="R555df510949248c1"/>
+    <p:sldId xmlns:r="http://schemas.openxmlformats.org/officeDocument/2006/relationships" id="257" r:id="Rd92fc1eee4ae4f09"/>
+    <p:sldId xmlns:r="http://schemas.openxmlformats.org/officeDocument/2006/relationships" id="258" r:id="Rd4a5d65a2dfc4dcf"/>
+    <p:sldId xmlns:r="http://schemas.openxmlformats.org/officeDocument/2006/relationships" id="259" r:id="R5687c285aad34d08"/>
+    <p:sldId xmlns:r="http://schemas.openxmlformats.org/officeDocument/2006/relationships" id="260" r:id="Rfffba3d74e6f41af"/>
+    <p:sldId xmlns:r="http://schemas.openxmlformats.org/officeDocument/2006/relationships" id="261" r:id="R9d6f9012d5ff4b41"/>
+    <p:sldId xmlns:r="http://schemas.openxmlformats.org/officeDocument/2006/relationships" id="262" r:id="R439ce1c169b4409f"/>
   </p:sldIdLst>
   <p:sldSz cx="15240000" cy="8572500"/>
   <p:notesSz cx="6858000" cy="9144000"/>
@@ -1111,7 +1111,7 @@
   </p:cSld>
   <p:clrMap bg1="lt1" tx1="dk1" bg2="lt2" tx2="dk2" accent1="accent1" accent2="accent2" accent3="accent3" accent4="accent4" accent5="accent5" accent6="accent6" hlink="hlink" folHlink="folHlink"/>
   <p:sldLayoutIdLst>
-    <p:sldLayoutId xmlns:r="http://schemas.openxmlformats.org/officeDocument/2006/relationships" id="2147483649" r:id="Rb74bc00e075542da"/>
+    <p:sldLayoutId xmlns:r="http://schemas.openxmlformats.org/officeDocument/2006/relationships" id="2147483649" r:id="R032075be249942b7"/>
   </p:sldLayoutIdLst>
   <p:txStyles>
     <p:titleStyle>
@@ -4236,7 +4236,7 @@
                 <a:latin typeface="Arial"/>
                 <a:ea typeface="Arial"/>
                 <a:cs typeface="Arial"/>
-                <a:hlinkClick xmlns:r="http://schemas.openxmlformats.org/officeDocument/2006/relationships" r:id="R7349f18f19fe43cb"/>
+                <a:hlinkClick xmlns:r="http://schemas.openxmlformats.org/officeDocument/2006/relationships" r:id="Rb5f8bdf0836047d2"/>
               </a:rPr>
               <a:t>READ THE FULL BRIEF  →  BRIEF.BRIDGEXCAPITAL.AI</a:t>
             </a:r>
@@ -14607,8 +14607,8 @@
         </p:nvSpPr>
         <p:spPr>
           <a:xfrm xmlns:a="http://schemas.openxmlformats.org/drawingml/2006/main">
-            <a:off x="1704975" y="4667250"/>
-            <a:ext cx="2209800" cy="609600"/>
+            <a:off x="1514475" y="4667250"/>
+            <a:ext cx="2590800" cy="609600"/>
           </a:xfrm>
           <a:prstGeom xmlns:a="http://schemas.openxmlformats.org/drawingml/2006/main" prst="rect">
             <a:avLst/>
@@ -14826,8 +14826,8 @@
         </p:nvSpPr>
         <p:spPr>
           <a:xfrm xmlns:a="http://schemas.openxmlformats.org/drawingml/2006/main">
-            <a:off x="6515100" y="4667250"/>
-            <a:ext cx="2209800" cy="609600"/>
+            <a:off x="6324600" y="4667250"/>
+            <a:ext cx="2590800" cy="609600"/>
           </a:xfrm>
           <a:prstGeom xmlns:a="http://schemas.openxmlformats.org/drawingml/2006/main" prst="rect">
             <a:avLst/>
@@ -14840,7 +14840,7 @@
         </p:spPr>
         <p:txBody>
           <a:bodyPr xmlns:a="http://schemas.openxmlformats.org/drawingml/2006/main" lIns="0" tIns="0" rIns="0" bIns="0" anchor="ctr">
-            <a:normAutofit fontScale="93257"/>
+            <a:normAutofit fontScale="100000"/>
           </a:bodyPr>
           <a:lstStyle xmlns:a="http://schemas.openxmlformats.org/drawingml/2006/main"/>
           <a:p xmlns:a="http://schemas.openxmlformats.org/drawingml/2006/main">
@@ -15045,8 +15045,8 @@
         </p:nvSpPr>
         <p:spPr>
           <a:xfrm xmlns:a="http://schemas.openxmlformats.org/drawingml/2006/main">
-            <a:off x="11325225" y="4667250"/>
-            <a:ext cx="2209800" cy="609600"/>
+            <a:off x="11134725" y="4667250"/>
+            <a:ext cx="2590800" cy="609600"/>
           </a:xfrm>
           <a:prstGeom xmlns:a="http://schemas.openxmlformats.org/drawingml/2006/main" prst="rect">
             <a:avLst/>
@@ -15059,7 +15059,7 @@
         </p:spPr>
         <p:txBody>
           <a:bodyPr xmlns:a="http://schemas.openxmlformats.org/drawingml/2006/main" lIns="0" tIns="0" rIns="0" bIns="0" anchor="ctr">
-            <a:normAutofit fontScale="87788"/>
+            <a:normAutofit fontScale="100000"/>
           </a:bodyPr>
           <a:lstStyle xmlns:a="http://schemas.openxmlformats.org/drawingml/2006/main"/>
           <a:p xmlns:a="http://schemas.openxmlformats.org/drawingml/2006/main">
@@ -16949,7 +16949,7 @@
                 <a:latin typeface="Arial"/>
                 <a:ea typeface="Arial"/>
                 <a:cs typeface="Arial"/>
-                <a:hlinkClick xmlns:r="http://schemas.openxmlformats.org/officeDocument/2006/relationships" r:id="Rcfe676c9e0ec4511"/>
+                <a:hlinkClick xmlns:r="http://schemas.openxmlformats.org/officeDocument/2006/relationships" r:id="R28a7e15345ee44a7"/>
               </a:rPr>
               <a:t>READ EDITION 005  →  BRIEF.BRIDGEXCAPITAL.AI</a:t>
             </a:r>

</xml_diff>